<commit_message>
Deck and handout disagreed about two gate checks
Today's LAB1 edits left slides 36 and 38 behind: Gate 2's card gained the
seven-test rule and Gate 4's gained the perturbation, and neither reached the
deck. Synced.

Gate 2's slide drops the scope rule from the code block, which was already
stated in that slide's own paragraph, and spends the line on the check that a
weak model actually fails: all seven tests cited.

Gate 4's now reads 'spike 1.0, then 0.3 -> 0.3' and 'no legend at all' - the
perturbation and the corrected pass condition, since a right chart has no
legend rather than a legend without an axis name in it.
</commit_message>
<xml_diff>
--- a/slides/Session 1 - Meet Your Agent.pptx
+++ b/slides/Session 1 - Meet Your Agent.pptx
@@ -20431,7 +20431,7 @@
                 <a:ea typeface="IBM Plex Mono" pitchFamily="34" charset="-122"/>
                 <a:cs typeface="IBM Plex Mono" pitchFamily="34" charset="-120"/>
               </a:rPr>
-              <a:t>  every done bullet has a row</a:t>
+              <a:t>  every bullet has a row,</a:t>
             </a:r>
             <a:endParaRPr lang="en-US" sz="1400" dirty="0"/>
           </a:p>
@@ -20451,7 +20451,7 @@
                 <a:ea typeface="IBM Plex Mono" pitchFamily="34" charset="-122"/>
                 <a:cs typeface="IBM Plex Mono" pitchFamily="34" charset="-120"/>
               </a:rPr>
-              <a:t>       pytest only backs core/</a:t>
+              <a:t>       all 7 tests cited, and</a:t>
             </a:r>
             <a:endParaRPr lang="en-US" sz="1400" dirty="0"/>
           </a:p>
@@ -21827,7 +21827,7 @@
                 <a:ea typeface="IBM Plex Mono" pitchFamily="34" charset="-122"/>
                 <a:cs typeface="IBM Plex Mono" pitchFamily="34" charset="-120"/>
               </a:rPr>
-              <a:t>       50 Hz spike reaches 1.0</a:t>
+              <a:t>       spike 1.0, then 0.3 -&gt; 0.3</a:t>
             </a:r>
             <a:endParaRPr lang="en-US" sz="1400" dirty="0"/>
           </a:p>
@@ -21847,7 +21847,7 @@
                 <a:ea typeface="IBM Plex Mono" pitchFamily="34" charset="-122"/>
                 <a:cs typeface="IBM Plex Mono" pitchFamily="34" charset="-120"/>
               </a:rPr>
-              <a:t>       no axis name in the legend</a:t>
+              <a:t>       and no legend at all</a:t>
             </a:r>
             <a:endParaRPr lang="en-US" sz="1400" dirty="0"/>
           </a:p>

</xml_diff>